<commit_message>
docs(report): add slide 10 on the ongoing H-f rerun (stale-trajectory filter)
The progress deck lacked the experiment currently in progress: training
only on samples from the current weights, to stop trajectories from
superseded weights updating the model. New slide 10 covers the problem
and its evidence (every batch after step 0 generated by the previous
weights, staleness 1.4-2.7x the step-0 floor), the diagnostic design and
validity checks, first-run results to day 9, and the rerun with its
step-aligned criteria (marked as a proposal, still unconfirmed in the
work log). Slides 8 and 9 now point to it. Originals unchanged; validate
passes.
</commit_message>
<xml_diff>
--- a/report/Openclaw-RL论文复现及迁移内容分享_MetaClaw进展.pptx
+++ b/report/Openclaw-RL论文复现及迁移内容分享_MetaClaw进展.pptx
@@ -17,6 +17,7 @@
     <p:sldId id="373" r:id="rId16"/>
     <p:sldId id="374" r:id="rId17"/>
     <p:sldId id="375" r:id="rId18"/>
+    <p:sldId id="376" r:id="rId19"/>
     <p:sldId id="367" r:id="rId7"/>
   </p:sldIdLst>
   <p:sldSz cx="12192000" cy="6858000"/>
@@ -7126,7 +7127,7 @@
                           <a:latin typeface="Segoe UI"/>
                           <a:ea typeface="微软雅黑"/>
                         </a:rPr>
-                        <a:t>步数没对齐、出现别的失效，未定论</a:t>
+                        <a:t>步数没对齐、出现别的失效，正在重跑</a:t>
                       </a:r>
                     </a:p>
                   </a:txBody>
@@ -7155,6 +7156,1538 @@
           </a:graphicData>
         </a:graphic>
       </p:graphicFrame>
+    </p:spTree>
+  </p:cSld>
+  <p:clrMapOvr>
+    <a:masterClrMapping/>
+  </p:clrMapOvr>
+</p:sld>
+</file>
+
+<file path=ppt/slides/slide11.xml><?xml version="1.0" encoding="utf-8"?>
+<p:sld xmlns:a="http://schemas.openxmlformats.org/drawingml/2006/main" xmlns:p="http://schemas.openxmlformats.org/presentationml/2006/main" xmlns:r="http://schemas.openxmlformats.org/officeDocument/2006/relationships">
+  <p:cSld>
+    <p:spTree>
+      <p:nvGrpSpPr>
+        <p:cNvPr id="1" name=""/>
+        <p:cNvGrpSpPr/>
+        <p:nvPr/>
+      </p:nvGrpSpPr>
+      <p:grpSpPr/>
+      <p:sp>
+        <p:nvSpPr>
+          <p:cNvPr id="2" name="Title 1"/>
+          <p:cNvSpPr>
+            <a:spLocks noGrp="1"/>
+          </p:cNvSpPr>
+          <p:nvPr>
+            <p:ph type="title"/>
+          </p:nvPr>
+        </p:nvSpPr>
+        <p:spPr>
+          <a:xfrm>
+            <a:off x="484632" y="256032"/>
+            <a:ext cx="11155680" cy="822960"/>
+          </a:xfrm>
+        </p:spPr>
+        <p:txBody>
+          <a:bodyPr/>
+          <a:lstStyle/>
+          <a:p>
+            <a:pPr algn="l"/>
+            <a:r>
+              <a:rPr lang="zh-CN" altLang="en-US" sz="2600" b="1" noProof="1">
+                <a:solidFill>
+                  <a:srgbClr val="262626"/>
+                </a:solidFill>
+                <a:latin typeface="Segoe UI"/>
+                <a:ea typeface="微软雅黑"/>
+              </a:rPr>
+              <a:t>正在进行：防止旧轨迹影响当前参数</a:t>
+            </a:r>
+          </a:p>
+        </p:txBody>
+      </p:sp>
+      <p:sp>
+        <p:nvSpPr>
+          <p:cNvPr id="3" name="Content Placeholder 2"/>
+          <p:cNvSpPr>
+            <a:spLocks noGrp="1"/>
+          </p:cNvSpPr>
+          <p:nvPr>
+            <p:ph idx="1"/>
+          </p:nvPr>
+        </p:nvSpPr>
+        <p:spPr/>
+        <p:txBody>
+          <a:bodyPr/>
+          <a:lstStyle/>
+          <a:p/>
+        </p:txBody>
+      </p:sp>
+      <p:sp>
+        <p:nvSpPr>
+          <p:cNvPr id="4" name="Panel"/>
+          <p:cNvSpPr/>
+          <p:nvPr/>
+        </p:nvSpPr>
+        <p:spPr>
+          <a:xfrm>
+            <a:off x="484632" y="1078992"/>
+            <a:ext cx="5532120" cy="2670048"/>
+          </a:xfrm>
+          <a:prstGeom prst="rect">
+            <a:avLst/>
+          </a:prstGeom>
+          <a:solidFill>
+            <a:srgbClr val="FFFFFF"/>
+          </a:solidFill>
+          <a:ln>
+            <a:noFill/>
+          </a:ln>
+          <a:effectLst/>
+        </p:spPr>
+        <p:style>
+          <a:lnRef idx="1">
+            <a:schemeClr val="accent1"/>
+          </a:lnRef>
+          <a:fillRef idx="3">
+            <a:schemeClr val="accent1"/>
+          </a:fillRef>
+          <a:effectRef idx="2">
+            <a:schemeClr val="accent1"/>
+          </a:effectRef>
+          <a:fontRef idx="minor">
+            <a:schemeClr val="lt1"/>
+          </a:fontRef>
+        </p:style>
+        <p:txBody>
+          <a:bodyPr rtlCol="0" anchor="ctr"/>
+          <a:lstStyle/>
+          <a:p>
+            <a:pPr algn="ctr"/>
+          </a:p>
+        </p:txBody>
+      </p:sp>
+      <p:sp>
+        <p:nvSpPr>
+          <p:cNvPr id="5" name="TextBox 4"/>
+          <p:cNvSpPr txBox="1"/>
+          <p:nvPr/>
+        </p:nvSpPr>
+        <p:spPr>
+          <a:xfrm>
+            <a:off x="649224" y="1188719"/>
+            <a:ext cx="5202936" cy="2487168"/>
+          </a:xfrm>
+          <a:prstGeom prst="rect">
+            <a:avLst/>
+          </a:prstGeom>
+          <a:noFill/>
+        </p:spPr>
+        <p:txBody>
+          <a:bodyPr wrap="square" lIns="0" rIns="0" tIns="0" bIns="0">
+            <a:spAutoFit/>
+          </a:bodyPr>
+          <a:lstStyle/>
+          <a:p>
+            <a:pPr marL="0" indent="0">
+              <a:lnSpc>
+                <a:spcPct val="110000"/>
+              </a:lnSpc>
+              <a:spcBef>
+                <a:spcPts val="0"/>
+              </a:spcBef>
+              <a:spcAft>
+                <a:spcPts val="600"/>
+              </a:spcAft>
+              <a:buNone/>
+            </a:pPr>
+            <a:r>
+              <a:rPr lang="zh-CN" altLang="en-US" sz="1500" b="1" noProof="1">
+                <a:solidFill>
+                  <a:srgbClr val="262626"/>
+                </a:solidFill>
+                <a:latin typeface="Segoe UI"/>
+                <a:ea typeface="微软雅黑"/>
+              </a:rPr>
+              <a:t>① 问题：训练数据整批来自上一版权重</a:t>
+            </a:r>
+          </a:p>
+          <a:p>
+            <a:pPr marL="0" indent="0">
+              <a:lnSpc>
+                <a:spcPct val="110000"/>
+              </a:lnSpc>
+              <a:spcBef>
+                <a:spcPts val="0"/>
+              </a:spcBef>
+              <a:spcAft>
+                <a:spcPts val="400"/>
+              </a:spcAft>
+              <a:buNone/>
+            </a:pPr>
+            <a:r>
+              <a:rPr lang="zh-CN" altLang="en-US" sz="1250" b="0" noProof="1">
+                <a:solidFill>
+                  <a:srgbClr val="262626"/>
+                </a:solidFill>
+                <a:latin typeface="Segoe UI"/>
+                <a:ea typeface="微软雅黑"/>
+              </a:rPr>
+              <a:t>· 官方 slime 异步循环：训练第 r 批时就在用 W_r 收集第 r+1 批，更新前先等收集完；除 step 0 外，每批都由上一版权重生成、新权重训练</a:t>
+            </a:r>
+          </a:p>
+          <a:p>
+            <a:pPr marL="0" indent="0">
+              <a:lnSpc>
+                <a:spcPct val="110000"/>
+              </a:lnSpc>
+              <a:spcBef>
+                <a:spcPts val="0"/>
+              </a:spcBef>
+              <a:spcAft>
+                <a:spcPts val="400"/>
+              </a:spcAft>
+              <a:buNone/>
+            </a:pPr>
+            <a:r>
+              <a:rPr lang="zh-CN" altLang="en-US" sz="1250" b="0" noProof="1">
+                <a:solidFill>
+                  <a:srgbClr val="262626"/>
+                </a:solidFill>
+                <a:latin typeface="Segoe UI"/>
+                <a:ea typeface="微软雅黑"/>
+              </a:rPr>
+              <a:t>· 没有重要性修正（--use-rollout-logprobs 关闭），旧样本被当作当前权重生成的来训练</a:t>
+            </a:r>
+          </a:p>
+          <a:p>
+            <a:pPr marL="0" indent="0">
+              <a:lnSpc>
+                <a:spcPct val="110000"/>
+              </a:lnSpc>
+              <a:spcBef>
+                <a:spcPts val="0"/>
+              </a:spcBef>
+              <a:spcAft>
+                <a:spcPts val="400"/>
+              </a:spcAft>
+              <a:buNone/>
+            </a:pPr>
+            <a:r>
+              <a:rPr lang="zh-CN" altLang="en-US" sz="1250" b="0" noProof="1">
+                <a:solidFill>
+                  <a:srgbClr val="262626"/>
+                </a:solidFill>
+                <a:latin typeface="Segoe UI"/>
+                <a:ea typeface="微软雅黑"/>
+              </a:rPr>
+              <a:t>· 同批 token 上「当前权重 vs 生成时权重」的对数概率差：step 0 底线 0.066，之后各步为底线的 1.4–2.7 倍</a:t>
+            </a:r>
+          </a:p>
+          <a:p>
+            <a:pPr marL="0" indent="0">
+              <a:lnSpc>
+                <a:spcPct val="110000"/>
+              </a:lnSpc>
+              <a:spcBef>
+                <a:spcPts val="0"/>
+              </a:spcBef>
+              <a:spcAft>
+                <a:spcPts val="0"/>
+              </a:spcAft>
+              <a:buNone/>
+            </a:pPr>
+            <a:r>
+              <a:rPr lang="zh-CN" altLang="en-US" sz="1250" b="0" noProof="1">
+                <a:solidFill>
+                  <a:srgbClr val="262626"/>
+                </a:solidFill>
+                <a:latin typeface="Segoe UI"/>
+                <a:ea typeface="微软雅黑"/>
+              </a:rPr>
+              <a:t>· MetaClaw 在技能库版本变化时清空样本缓冲区；本实验把这一原则推广到权重版本</a:t>
+            </a:r>
+          </a:p>
+        </p:txBody>
+      </p:sp>
+      <p:sp>
+        <p:nvSpPr>
+          <p:cNvPr id="6" name="Panel"/>
+          <p:cNvSpPr/>
+          <p:nvPr/>
+        </p:nvSpPr>
+        <p:spPr>
+          <a:xfrm>
+            <a:off x="6172200" y="1078992"/>
+            <a:ext cx="5532120" cy="2670048"/>
+          </a:xfrm>
+          <a:prstGeom prst="rect">
+            <a:avLst/>
+          </a:prstGeom>
+          <a:solidFill>
+            <a:srgbClr val="FFFFFF"/>
+          </a:solidFill>
+          <a:ln>
+            <a:noFill/>
+          </a:ln>
+          <a:effectLst/>
+        </p:spPr>
+        <p:style>
+          <a:lnRef idx="1">
+            <a:schemeClr val="accent1"/>
+          </a:lnRef>
+          <a:fillRef idx="3">
+            <a:schemeClr val="accent1"/>
+          </a:fillRef>
+          <a:effectRef idx="2">
+            <a:schemeClr val="accent1"/>
+          </a:effectRef>
+          <a:fontRef idx="minor">
+            <a:schemeClr val="lt1"/>
+          </a:fontRef>
+        </p:style>
+        <p:txBody>
+          <a:bodyPr rtlCol="0" anchor="ctr"/>
+          <a:lstStyle/>
+          <a:p>
+            <a:pPr algn="ctr"/>
+          </a:p>
+        </p:txBody>
+      </p:sp>
+      <p:sp>
+        <p:nvSpPr>
+          <p:cNvPr id="7" name="TextBox 6"/>
+          <p:cNvSpPr txBox="1"/>
+          <p:nvPr/>
+        </p:nvSpPr>
+        <p:spPr>
+          <a:xfrm>
+            <a:off x="6336792" y="1188719"/>
+            <a:ext cx="5202936" cy="2487168"/>
+          </a:xfrm>
+          <a:prstGeom prst="rect">
+            <a:avLst/>
+          </a:prstGeom>
+          <a:noFill/>
+        </p:spPr>
+        <p:txBody>
+          <a:bodyPr wrap="square" lIns="0" rIns="0" tIns="0" bIns="0">
+            <a:spAutoFit/>
+          </a:bodyPr>
+          <a:lstStyle/>
+          <a:p>
+            <a:pPr marL="0" indent="0">
+              <a:lnSpc>
+                <a:spcPct val="110000"/>
+              </a:lnSpc>
+              <a:spcBef>
+                <a:spcPts val="0"/>
+              </a:spcBef>
+              <a:spcAft>
+                <a:spcPts val="600"/>
+              </a:spcAft>
+              <a:buNone/>
+            </a:pPr>
+            <a:r>
+              <a:rPr lang="zh-CN" altLang="en-US" sz="1500" b="1" noProof="1">
+                <a:solidFill>
+                  <a:srgbClr val="262626"/>
+                </a:solidFill>
+                <a:latin typeface="Segoe UI"/>
+                <a:ea typeface="微软雅黑"/>
+              </a:rPr>
+              <a:t>② 做法：只用当前权重生成的样本训练</a:t>
+            </a:r>
+          </a:p>
+          <a:p>
+            <a:pPr marL="0" indent="0">
+              <a:lnSpc>
+                <a:spcPct val="110000"/>
+              </a:lnSpc>
+              <a:spcBef>
+                <a:spcPts val="0"/>
+              </a:spcBef>
+              <a:spcAft>
+                <a:spcPts val="400"/>
+              </a:spcAft>
+              <a:buNone/>
+            </a:pPr>
+            <a:r>
+              <a:rPr lang="zh-CN" altLang="en-US" sz="1250" b="0" noProof="1">
+                <a:solidFill>
+                  <a:srgbClr val="262626"/>
+                </a:solidFill>
+                <a:latin typeface="Segoe UI"/>
+                <a:ea typeface="微软雅黑"/>
+              </a:rPr>
+              <a:t>· 先更新权重、再收集下一批；训练期间 agent 照常运行，环境不变（无暂停、无 503）</a:t>
+            </a:r>
+          </a:p>
+          <a:p>
+            <a:pPr marL="0" indent="0">
+              <a:lnSpc>
+                <a:spcPct val="110000"/>
+              </a:lnSpc>
+              <a:spcBef>
+                <a:spcPts val="0"/>
+              </a:spcBef>
+              <a:spcAft>
+                <a:spcPts val="400"/>
+              </a:spcAft>
+              <a:buNone/>
+            </a:pPr>
+            <a:r>
+              <a:rPr lang="zh-CN" altLang="en-US" sz="1250" b="0" noProof="1">
+                <a:solidFill>
+                  <a:srgbClr val="262626"/>
+                </a:solidFill>
+                <a:latin typeface="Segoe UI"/>
+                <a:ea typeface="微软雅黑"/>
+              </a:rPr>
+              <a:t>· 每个 turn 记录生成它的权重版本（SGLang 返回的 weight_version），凑批时只保留所有 turn 都是当前版本的轨迹</a:t>
+            </a:r>
+          </a:p>
+          <a:p>
+            <a:pPr marL="0" indent="0">
+              <a:lnSpc>
+                <a:spcPct val="110000"/>
+              </a:lnSpc>
+              <a:spcBef>
+                <a:spcPts val="0"/>
+              </a:spcBef>
+              <a:spcAft>
+                <a:spcPts val="400"/>
+              </a:spcAft>
+              <a:buNone/>
+            </a:pPr>
+            <a:r>
+              <a:rPr lang="zh-CN" altLang="en-US" sz="1250" b="0" noProof="1">
+                <a:solidFill>
+                  <a:srgbClr val="262626"/>
+                </a:solidFill>
+                <a:latin typeface="Segoe UI"/>
+                <a:ea typeface="微软雅黑"/>
+              </a:rPr>
+              <a:t>· 有效性检查：目标版本每步 +1；无版本标记的样本为 0；丢弃与保留轨迹的长度比 &lt; 1.5（排除“只是丢掉了长轨迹”）</a:t>
+            </a:r>
+          </a:p>
+          <a:p>
+            <a:pPr marL="0" indent="0">
+              <a:lnSpc>
+                <a:spcPct val="110000"/>
+              </a:lnSpc>
+              <a:spcBef>
+                <a:spcPts val="0"/>
+              </a:spcBef>
+              <a:spcAft>
+                <a:spcPts val="0"/>
+              </a:spcAft>
+              <a:buNone/>
+            </a:pPr>
+            <a:r>
+              <a:rPr lang="zh-CN" altLang="en-US" sz="1250" b="0" noProof="1">
+                <a:solidFill>
+                  <a:srgbClr val="7F7F7F"/>
+                </a:solidFill>
+                <a:latin typeface="Segoe UI"/>
+                <a:ea typeface="微软雅黑"/>
+              </a:rPr>
+              <a:t>· 临时诊断开关（METACLAW_ONPOLICY），只用于确认假设是否成立，结论出来后回退，不是修复方案</a:t>
+            </a:r>
+          </a:p>
+        </p:txBody>
+      </p:sp>
+      <p:sp>
+        <p:nvSpPr>
+          <p:cNvPr id="8" name="Panel"/>
+          <p:cNvSpPr/>
+          <p:nvPr/>
+        </p:nvSpPr>
+        <p:spPr>
+          <a:xfrm>
+            <a:off x="484632" y="3904487"/>
+            <a:ext cx="5532120" cy="2788920"/>
+          </a:xfrm>
+          <a:prstGeom prst="rect">
+            <a:avLst/>
+          </a:prstGeom>
+          <a:solidFill>
+            <a:srgbClr val="FFFFFF"/>
+          </a:solidFill>
+          <a:ln>
+            <a:noFill/>
+          </a:ln>
+          <a:effectLst/>
+        </p:spPr>
+        <p:style>
+          <a:lnRef idx="1">
+            <a:schemeClr val="accent1"/>
+          </a:lnRef>
+          <a:fillRef idx="3">
+            <a:schemeClr val="accent1"/>
+          </a:fillRef>
+          <a:effectRef idx="2">
+            <a:schemeClr val="accent1"/>
+          </a:effectRef>
+          <a:fontRef idx="minor">
+            <a:schemeClr val="lt1"/>
+          </a:fontRef>
+        </p:style>
+        <p:txBody>
+          <a:bodyPr rtlCol="0" anchor="ctr"/>
+          <a:lstStyle/>
+          <a:p>
+            <a:pPr algn="ctr"/>
+          </a:p>
+        </p:txBody>
+      </p:sp>
+      <p:sp>
+        <p:nvSpPr>
+          <p:cNvPr id="9" name="TextBox 8"/>
+          <p:cNvSpPr txBox="1"/>
+          <p:nvPr/>
+        </p:nvSpPr>
+        <p:spPr>
+          <a:xfrm>
+            <a:off x="649224" y="4014215"/>
+            <a:ext cx="5202936" cy="274320"/>
+          </a:xfrm>
+          <a:prstGeom prst="rect">
+            <a:avLst/>
+          </a:prstGeom>
+          <a:noFill/>
+        </p:spPr>
+        <p:txBody>
+          <a:bodyPr wrap="square" lIns="0" rIns="0" tIns="0" bIns="0">
+            <a:spAutoFit/>
+          </a:bodyPr>
+          <a:lstStyle/>
+          <a:p>
+            <a:pPr marL="0" indent="0">
+              <a:lnSpc>
+                <a:spcPct val="105000"/>
+              </a:lnSpc>
+              <a:spcBef>
+                <a:spcPts val="0"/>
+              </a:spcBef>
+              <a:spcAft>
+                <a:spcPts val="0"/>
+              </a:spcAft>
+              <a:buNone/>
+            </a:pPr>
+            <a:r>
+              <a:rPr lang="zh-CN" altLang="en-US" sz="1500" b="1" noProof="1">
+                <a:solidFill>
+                  <a:srgbClr val="262626"/>
+                </a:solidFill>
+                <a:latin typeface="Segoe UI"/>
+                <a:ea typeface="微软雅黑"/>
+              </a:rPr>
+              <a:t>③ 首趟结果（混合训练，day01–09）</a:t>
+            </a:r>
+          </a:p>
+        </p:txBody>
+      </p:sp>
+      <p:graphicFrame>
+        <p:nvGraphicFramePr>
+          <p:cNvPr id="10" name="Table 9"/>
+          <p:cNvGraphicFramePr>
+            <a:graphicFrameLocks noGrp="1"/>
+          </p:cNvGraphicFramePr>
+          <p:nvPr/>
+        </p:nvGraphicFramePr>
+        <p:xfrm>
+          <a:off x="649224" y="4379975"/>
+          <a:ext cx="5166360" cy="1499616"/>
+        </p:xfrm>
+        <a:graphic>
+          <a:graphicData uri="http://schemas.openxmlformats.org/drawingml/2006/table">
+            <a:tbl>
+              <a:tblPr firstRow="0" bandRow="0">
+                <a:tableStyleId>{2D5ABB26-0587-4C30-8999-92F81FD0307C}</a:tableStyleId>
+              </a:tblPr>
+              <a:tblGrid>
+                <a:gridCol w="2423160"/>
+                <a:gridCol w="1371600"/>
+                <a:gridCol w="1371600"/>
+              </a:tblGrid>
+              <a:tr h="292608">
+                <a:tc>
+                  <a:txBody>
+                    <a:bodyPr wrap="square"/>
+                    <a:lstStyle/>
+                    <a:p>
+                      <a:pPr marL="0" indent="0" algn="l">
+                        <a:lnSpc>
+                          <a:spcPct val="100000"/>
+                        </a:lnSpc>
+                        <a:spcBef>
+                          <a:spcPts val="0"/>
+                        </a:spcBef>
+                        <a:spcAft>
+                          <a:spcPts val="0"/>
+                        </a:spcAft>
+                        <a:buNone/>
+                      </a:pPr>
+                      <a:r>
+                        <a:rPr lang="zh-CN" altLang="en-US" sz="1200" b="1" noProof="1">
+                          <a:solidFill>
+                            <a:srgbClr val="262626"/>
+                          </a:solidFill>
+                          <a:latin typeface="Segoe UI"/>
+                          <a:ea typeface="微软雅黑"/>
+                        </a:rPr>
+                        <a:t/>
+                      </a:r>
+                    </a:p>
+                  </a:txBody>
+                  <a:tcPr anchor="ctr" marL="54864" marR="54864" marT="27432" marB="27432">
+                    <a:lnL w="0">
+                      <a:noFill/>
+                    </a:lnL>
+                    <a:lnR w="0">
+                      <a:noFill/>
+                    </a:lnR>
+                    <a:lnT w="15875">
+                      <a:solidFill>
+                        <a:srgbClr val="404040"/>
+                      </a:solidFill>
+                    </a:lnT>
+                    <a:lnB w="9525">
+                      <a:solidFill>
+                        <a:srgbClr val="404040"/>
+                      </a:solidFill>
+                    </a:lnB>
+                    <a:solidFill>
+                      <a:srgbClr val="FFFFFF"/>
+                    </a:solidFill>
+                  </a:tcPr>
+                </a:tc>
+                <a:tc>
+                  <a:txBody>
+                    <a:bodyPr wrap="square"/>
+                    <a:lstStyle/>
+                    <a:p>
+                      <a:pPr marL="0" indent="0" algn="ctr">
+                        <a:lnSpc>
+                          <a:spcPct val="100000"/>
+                        </a:lnSpc>
+                        <a:spcBef>
+                          <a:spcPts val="0"/>
+                        </a:spcBef>
+                        <a:spcAft>
+                          <a:spcPts val="0"/>
+                        </a:spcAft>
+                        <a:buNone/>
+                      </a:pPr>
+                      <a:r>
+                        <a:rPr lang="zh-CN" altLang="en-US" sz="1200" b="1" noProof="1">
+                          <a:solidFill>
+                            <a:srgbClr val="262626"/>
+                          </a:solidFill>
+                          <a:latin typeface="Segoe UI"/>
+                          <a:ea typeface="微软雅黑"/>
+                        </a:rPr>
+                        <a:t>混合（对照）</a:t>
+                      </a:r>
+                    </a:p>
+                  </a:txBody>
+                  <a:tcPr anchor="ctr" marL="54864" marR="54864" marT="27432" marB="27432">
+                    <a:lnL w="0">
+                      <a:noFill/>
+                    </a:lnL>
+                    <a:lnR w="0">
+                      <a:noFill/>
+                    </a:lnR>
+                    <a:lnT w="15875">
+                      <a:solidFill>
+                        <a:srgbClr val="404040"/>
+                      </a:solidFill>
+                    </a:lnT>
+                    <a:lnB w="9525">
+                      <a:solidFill>
+                        <a:srgbClr val="404040"/>
+                      </a:solidFill>
+                    </a:lnB>
+                    <a:solidFill>
+                      <a:srgbClr val="FFFFFF"/>
+                    </a:solidFill>
+                  </a:tcPr>
+                </a:tc>
+                <a:tc>
+                  <a:txBody>
+                    <a:bodyPr wrap="square"/>
+                    <a:lstStyle/>
+                    <a:p>
+                      <a:pPr marL="0" indent="0" algn="ctr">
+                        <a:lnSpc>
+                          <a:spcPct val="100000"/>
+                        </a:lnSpc>
+                        <a:spcBef>
+                          <a:spcPts val="0"/>
+                        </a:spcBef>
+                        <a:spcAft>
+                          <a:spcPts val="0"/>
+                        </a:spcAft>
+                        <a:buNone/>
+                      </a:pPr>
+                      <a:r>
+                        <a:rPr lang="zh-CN" altLang="en-US" sz="1200" b="1" noProof="1">
+                          <a:solidFill>
+                            <a:srgbClr val="262626"/>
+                          </a:solidFill>
+                          <a:latin typeface="Segoe UI"/>
+                          <a:ea typeface="微软雅黑"/>
+                        </a:rPr>
+                        <a:t>混合 + 同策略</a:t>
+                      </a:r>
+                    </a:p>
+                  </a:txBody>
+                  <a:tcPr anchor="ctr" marL="54864" marR="54864" marT="27432" marB="27432">
+                    <a:lnL w="0">
+                      <a:noFill/>
+                    </a:lnL>
+                    <a:lnR w="0">
+                      <a:noFill/>
+                    </a:lnR>
+                    <a:lnT w="15875">
+                      <a:solidFill>
+                        <a:srgbClr val="404040"/>
+                      </a:solidFill>
+                    </a:lnT>
+                    <a:lnB w="9525">
+                      <a:solidFill>
+                        <a:srgbClr val="404040"/>
+                      </a:solidFill>
+                    </a:lnB>
+                    <a:solidFill>
+                      <a:srgbClr val="FFFFFF"/>
+                    </a:solidFill>
+                  </a:tcPr>
+                </a:tc>
+              </a:tr>
+              <a:tr h="301752">
+                <a:tc>
+                  <a:txBody>
+                    <a:bodyPr wrap="square"/>
+                    <a:lstStyle/>
+                    <a:p>
+                      <a:pPr marL="0" indent="0" algn="l">
+                        <a:lnSpc>
+                          <a:spcPct val="100000"/>
+                        </a:lnSpc>
+                        <a:spcBef>
+                          <a:spcPts val="0"/>
+                        </a:spcBef>
+                        <a:spcAft>
+                          <a:spcPts val="0"/>
+                        </a:spcAft>
+                        <a:buNone/>
+                      </a:pPr>
+                      <a:r>
+                        <a:rPr lang="zh-CN" altLang="en-US" sz="1150" b="0" noProof="1">
+                          <a:solidFill>
+                            <a:srgbClr val="262626"/>
+                          </a:solidFill>
+                          <a:latin typeface="Segoe UI"/>
+                          <a:ea typeface="微软雅黑"/>
+                        </a:rPr>
+                        <a:t>day09 复读占比</a:t>
+                      </a:r>
+                    </a:p>
+                  </a:txBody>
+                  <a:tcPr anchor="ctr" marL="54864" marR="54864" marT="27432" marB="27432">
+                    <a:lnL w="0">
+                      <a:noFill/>
+                    </a:lnL>
+                    <a:lnR w="0">
+                      <a:noFill/>
+                    </a:lnR>
+                    <a:lnT w="0">
+                      <a:noFill/>
+                    </a:lnT>
+                    <a:lnB w="6350">
+                      <a:solidFill>
+                        <a:srgbClr val="BFBFBF"/>
+                      </a:solidFill>
+                    </a:lnB>
+                    <a:solidFill>
+                      <a:srgbClr val="FFFFFF"/>
+                    </a:solidFill>
+                  </a:tcPr>
+                </a:tc>
+                <a:tc>
+                  <a:txBody>
+                    <a:bodyPr wrap="square"/>
+                    <a:lstStyle/>
+                    <a:p>
+                      <a:pPr marL="0" indent="0" algn="ctr">
+                        <a:lnSpc>
+                          <a:spcPct val="100000"/>
+                        </a:lnSpc>
+                        <a:spcBef>
+                          <a:spcPts val="0"/>
+                        </a:spcBef>
+                        <a:spcAft>
+                          <a:spcPts val="0"/>
+                        </a:spcAft>
+                        <a:buNone/>
+                      </a:pPr>
+                      <a:r>
+                        <a:rPr lang="zh-CN" altLang="en-US" sz="1150" b="0" noProof="1">
+                          <a:solidFill>
+                            <a:srgbClr val="B02A2A"/>
+                          </a:solidFill>
+                          <a:latin typeface="Segoe UI"/>
+                          <a:ea typeface="微软雅黑"/>
+                        </a:rPr>
+                        <a:t>29%</a:t>
+                      </a:r>
+                    </a:p>
+                  </a:txBody>
+                  <a:tcPr anchor="ctr" marL="54864" marR="54864" marT="27432" marB="27432">
+                    <a:lnL w="0">
+                      <a:noFill/>
+                    </a:lnL>
+                    <a:lnR w="0">
+                      <a:noFill/>
+                    </a:lnR>
+                    <a:lnT w="0">
+                      <a:noFill/>
+                    </a:lnT>
+                    <a:lnB w="6350">
+                      <a:solidFill>
+                        <a:srgbClr val="BFBFBF"/>
+                      </a:solidFill>
+                    </a:lnB>
+                    <a:solidFill>
+                      <a:srgbClr val="FFFFFF"/>
+                    </a:solidFill>
+                  </a:tcPr>
+                </a:tc>
+                <a:tc>
+                  <a:txBody>
+                    <a:bodyPr wrap="square"/>
+                    <a:lstStyle/>
+                    <a:p>
+                      <a:pPr marL="0" indent="0" algn="ctr">
+                        <a:lnSpc>
+                          <a:spcPct val="100000"/>
+                        </a:lnSpc>
+                        <a:spcBef>
+                          <a:spcPts val="0"/>
+                        </a:spcBef>
+                        <a:spcAft>
+                          <a:spcPts val="0"/>
+                        </a:spcAft>
+                        <a:buNone/>
+                      </a:pPr>
+                      <a:r>
+                        <a:rPr lang="zh-CN" altLang="en-US" sz="1150" b="0" noProof="1">
+                          <a:solidFill>
+                            <a:srgbClr val="262626"/>
+                          </a:solidFill>
+                          <a:latin typeface="Segoe UI"/>
+                          <a:ea typeface="微软雅黑"/>
+                        </a:rPr>
+                        <a:t>0%</a:t>
+                      </a:r>
+                    </a:p>
+                  </a:txBody>
+                  <a:tcPr anchor="ctr" marL="54864" marR="54864" marT="27432" marB="27432">
+                    <a:lnL w="0">
+                      <a:noFill/>
+                    </a:lnL>
+                    <a:lnR w="0">
+                      <a:noFill/>
+                    </a:lnR>
+                    <a:lnT w="0">
+                      <a:noFill/>
+                    </a:lnT>
+                    <a:lnB w="6350">
+                      <a:solidFill>
+                        <a:srgbClr val="BFBFBF"/>
+                      </a:solidFill>
+                    </a:lnB>
+                    <a:solidFill>
+                      <a:srgbClr val="FFFFFF"/>
+                    </a:solidFill>
+                  </a:tcPr>
+                </a:tc>
+              </a:tr>
+              <a:tr h="301752">
+                <a:tc>
+                  <a:txBody>
+                    <a:bodyPr wrap="square"/>
+                    <a:lstStyle/>
+                    <a:p>
+                      <a:pPr marL="0" indent="0" algn="l">
+                        <a:lnSpc>
+                          <a:spcPct val="100000"/>
+                        </a:lnSpc>
+                        <a:spcBef>
+                          <a:spcPts val="0"/>
+                        </a:spcBef>
+                        <a:spcAft>
+                          <a:spcPts val="0"/>
+                        </a:spcAft>
+                        <a:buNone/>
+                      </a:pPr>
+                      <a:r>
+                        <a:rPr lang="zh-CN" altLang="en-US" sz="1150" b="0" noProof="1">
+                          <a:solidFill>
+                            <a:srgbClr val="262626"/>
+                          </a:solidFill>
+                          <a:latin typeface="Segoe UI"/>
+                          <a:ea typeface="微软雅黑"/>
+                        </a:rPr>
+                        <a:t>day09 结束时训练步</a:t>
+                      </a:r>
+                    </a:p>
+                  </a:txBody>
+                  <a:tcPr anchor="ctr" marL="54864" marR="54864" marT="27432" marB="27432">
+                    <a:lnL w="0">
+                      <a:noFill/>
+                    </a:lnL>
+                    <a:lnR w="0">
+                      <a:noFill/>
+                    </a:lnR>
+                    <a:lnT w="0">
+                      <a:noFill/>
+                    </a:lnT>
+                    <a:lnB w="6350">
+                      <a:solidFill>
+                        <a:srgbClr val="BFBFBF"/>
+                      </a:solidFill>
+                    </a:lnB>
+                    <a:solidFill>
+                      <a:srgbClr val="FFFFFF"/>
+                    </a:solidFill>
+                  </a:tcPr>
+                </a:tc>
+                <a:tc>
+                  <a:txBody>
+                    <a:bodyPr wrap="square"/>
+                    <a:lstStyle/>
+                    <a:p>
+                      <a:pPr marL="0" indent="0" algn="ctr">
+                        <a:lnSpc>
+                          <a:spcPct val="100000"/>
+                        </a:lnSpc>
+                        <a:spcBef>
+                          <a:spcPts val="0"/>
+                        </a:spcBef>
+                        <a:spcAft>
+                          <a:spcPts val="0"/>
+                        </a:spcAft>
+                        <a:buNone/>
+                      </a:pPr>
+                      <a:r>
+                        <a:rPr lang="zh-CN" altLang="en-US" sz="1150" b="0" noProof="1">
+                          <a:solidFill>
+                            <a:srgbClr val="262626"/>
+                          </a:solidFill>
+                          <a:latin typeface="Segoe UI"/>
+                          <a:ea typeface="微软雅黑"/>
+                        </a:rPr>
+                        <a:t>step 11</a:t>
+                      </a:r>
+                    </a:p>
+                  </a:txBody>
+                  <a:tcPr anchor="ctr" marL="54864" marR="54864" marT="27432" marB="27432">
+                    <a:lnL w="0">
+                      <a:noFill/>
+                    </a:lnL>
+                    <a:lnR w="0">
+                      <a:noFill/>
+                    </a:lnR>
+                    <a:lnT w="0">
+                      <a:noFill/>
+                    </a:lnT>
+                    <a:lnB w="6350">
+                      <a:solidFill>
+                        <a:srgbClr val="BFBFBF"/>
+                      </a:solidFill>
+                    </a:lnB>
+                    <a:solidFill>
+                      <a:srgbClr val="FFFFFF"/>
+                    </a:solidFill>
+                  </a:tcPr>
+                </a:tc>
+                <a:tc>
+                  <a:txBody>
+                    <a:bodyPr wrap="square"/>
+                    <a:lstStyle/>
+                    <a:p>
+                      <a:pPr marL="0" indent="0" algn="ctr">
+                        <a:lnSpc>
+                          <a:spcPct val="100000"/>
+                        </a:lnSpc>
+                        <a:spcBef>
+                          <a:spcPts val="0"/>
+                        </a:spcBef>
+                        <a:spcAft>
+                          <a:spcPts val="0"/>
+                        </a:spcAft>
+                        <a:buNone/>
+                      </a:pPr>
+                      <a:r>
+                        <a:rPr lang="zh-CN" altLang="en-US" sz="1150" b="0" noProof="1">
+                          <a:solidFill>
+                            <a:srgbClr val="262626"/>
+                          </a:solidFill>
+                          <a:latin typeface="Segoe UI"/>
+                          <a:ea typeface="微软雅黑"/>
+                        </a:rPr>
+                        <a:t>step 7</a:t>
+                      </a:r>
+                    </a:p>
+                  </a:txBody>
+                  <a:tcPr anchor="ctr" marL="54864" marR="54864" marT="27432" marB="27432">
+                    <a:lnL w="0">
+                      <a:noFill/>
+                    </a:lnL>
+                    <a:lnR w="0">
+                      <a:noFill/>
+                    </a:lnR>
+                    <a:lnT w="0">
+                      <a:noFill/>
+                    </a:lnT>
+                    <a:lnB w="6350">
+                      <a:solidFill>
+                        <a:srgbClr val="BFBFBF"/>
+                      </a:solidFill>
+                    </a:lnB>
+                    <a:solidFill>
+                      <a:srgbClr val="FFFFFF"/>
+                    </a:solidFill>
+                  </a:tcPr>
+                </a:tc>
+              </a:tr>
+              <a:tr h="301752">
+                <a:tc>
+                  <a:txBody>
+                    <a:bodyPr wrap="square"/>
+                    <a:lstStyle/>
+                    <a:p>
+                      <a:pPr marL="0" indent="0" algn="l">
+                        <a:lnSpc>
+                          <a:spcPct val="100000"/>
+                        </a:lnSpc>
+                        <a:spcBef>
+                          <a:spcPts val="0"/>
+                        </a:spcBef>
+                        <a:spcAft>
+                          <a:spcPts val="0"/>
+                        </a:spcAft>
+                        <a:buNone/>
+                      </a:pPr>
+                      <a:r>
+                        <a:rPr lang="zh-CN" altLang="en-US" sz="1150" b="0" noProof="1">
+                          <a:solidFill>
+                            <a:srgbClr val="262626"/>
+                          </a:solidFill>
+                          <a:latin typeface="Segoe UI"/>
+                          <a:ea typeface="微软雅黑"/>
+                        </a:rPr>
+                        <a:t>样本新旧差（相对 step 0 底线）</a:t>
+                      </a:r>
+                    </a:p>
+                  </a:txBody>
+                  <a:tcPr anchor="ctr" marL="54864" marR="54864" marT="27432" marB="27432">
+                    <a:lnL w="0">
+                      <a:noFill/>
+                    </a:lnL>
+                    <a:lnR w="0">
+                      <a:noFill/>
+                    </a:lnR>
+                    <a:lnT w="0">
+                      <a:noFill/>
+                    </a:lnT>
+                    <a:lnB w="6350">
+                      <a:solidFill>
+                        <a:srgbClr val="BFBFBF"/>
+                      </a:solidFill>
+                    </a:lnB>
+                    <a:solidFill>
+                      <a:srgbClr val="FFFFFF"/>
+                    </a:solidFill>
+                  </a:tcPr>
+                </a:tc>
+                <a:tc>
+                  <a:txBody>
+                    <a:bodyPr wrap="square"/>
+                    <a:lstStyle/>
+                    <a:p>
+                      <a:pPr marL="0" indent="0" algn="ctr">
+                        <a:lnSpc>
+                          <a:spcPct val="100000"/>
+                        </a:lnSpc>
+                        <a:spcBef>
+                          <a:spcPts val="0"/>
+                        </a:spcBef>
+                        <a:spcAft>
+                          <a:spcPts val="0"/>
+                        </a:spcAft>
+                        <a:buNone/>
+                      </a:pPr>
+                      <a:r>
+                        <a:rPr lang="zh-CN" altLang="en-US" sz="1150" b="0" noProof="1">
+                          <a:solidFill>
+                            <a:srgbClr val="262626"/>
+                          </a:solidFill>
+                          <a:latin typeface="Segoe UI"/>
+                          <a:ea typeface="微软雅黑"/>
+                        </a:rPr>
+                        <a:t>1.4–2.7×</a:t>
+                      </a:r>
+                    </a:p>
+                  </a:txBody>
+                  <a:tcPr anchor="ctr" marL="54864" marR="54864" marT="27432" marB="27432">
+                    <a:lnL w="0">
+                      <a:noFill/>
+                    </a:lnL>
+                    <a:lnR w="0">
+                      <a:noFill/>
+                    </a:lnR>
+                    <a:lnT w="0">
+                      <a:noFill/>
+                    </a:lnT>
+                    <a:lnB w="6350">
+                      <a:solidFill>
+                        <a:srgbClr val="BFBFBF"/>
+                      </a:solidFill>
+                    </a:lnB>
+                    <a:solidFill>
+                      <a:srgbClr val="FFFFFF"/>
+                    </a:solidFill>
+                  </a:tcPr>
+                </a:tc>
+                <a:tc>
+                  <a:txBody>
+                    <a:bodyPr wrap="square"/>
+                    <a:lstStyle/>
+                    <a:p>
+                      <a:pPr marL="0" indent="0" algn="ctr">
+                        <a:lnSpc>
+                          <a:spcPct val="100000"/>
+                        </a:lnSpc>
+                        <a:spcBef>
+                          <a:spcPts val="0"/>
+                        </a:spcBef>
+                        <a:spcAft>
+                          <a:spcPts val="0"/>
+                        </a:spcAft>
+                        <a:buNone/>
+                      </a:pPr>
+                      <a:r>
+                        <a:rPr lang="zh-CN" altLang="en-US" sz="1150" b="0" noProof="1">
+                          <a:solidFill>
+                            <a:srgbClr val="262626"/>
+                          </a:solidFill>
+                          <a:latin typeface="Segoe UI"/>
+                          <a:ea typeface="微软雅黑"/>
+                        </a:rPr>
+                        <a:t>多数步 0.75–0.96×</a:t>
+                      </a:r>
+                    </a:p>
+                  </a:txBody>
+                  <a:tcPr anchor="ctr" marL="54864" marR="54864" marT="27432" marB="27432">
+                    <a:lnL w="0">
+                      <a:noFill/>
+                    </a:lnL>
+                    <a:lnR w="0">
+                      <a:noFill/>
+                    </a:lnR>
+                    <a:lnT w="0">
+                      <a:noFill/>
+                    </a:lnT>
+                    <a:lnB w="6350">
+                      <a:solidFill>
+                        <a:srgbClr val="BFBFBF"/>
+                      </a:solidFill>
+                    </a:lnB>
+                    <a:solidFill>
+                      <a:srgbClr val="FFFFFF"/>
+                    </a:solidFill>
+                  </a:tcPr>
+                </a:tc>
+              </a:tr>
+              <a:tr h="301752">
+                <a:tc>
+                  <a:txBody>
+                    <a:bodyPr wrap="square"/>
+                    <a:lstStyle/>
+                    <a:p>
+                      <a:pPr marL="0" indent="0" algn="l">
+                        <a:lnSpc>
+                          <a:spcPct val="100000"/>
+                        </a:lnSpc>
+                        <a:spcBef>
+                          <a:spcPts val="0"/>
+                        </a:spcBef>
+                        <a:spcAft>
+                          <a:spcPts val="0"/>
+                        </a:spcAft>
+                        <a:buNone/>
+                      </a:pPr>
+                      <a:r>
+                        <a:rPr lang="zh-CN" altLang="en-US" sz="1150" b="0" noProof="1">
+                          <a:solidFill>
+                            <a:srgbClr val="262626"/>
+                          </a:solidFill>
+                          <a:latin typeface="Segoe UI"/>
+                          <a:ea typeface="微软雅黑"/>
+                        </a:rPr>
+                        <a:t>有效性检查</a:t>
+                      </a:r>
+                    </a:p>
+                  </a:txBody>
+                  <a:tcPr anchor="ctr" marL="54864" marR="54864" marT="27432" marB="27432">
+                    <a:lnL w="0">
+                      <a:noFill/>
+                    </a:lnL>
+                    <a:lnR w="0">
+                      <a:noFill/>
+                    </a:lnR>
+                    <a:lnT w="0">
+                      <a:noFill/>
+                    </a:lnT>
+                    <a:lnB w="15875">
+                      <a:solidFill>
+                        <a:srgbClr val="404040"/>
+                      </a:solidFill>
+                    </a:lnB>
+                    <a:solidFill>
+                      <a:srgbClr val="FFFFFF"/>
+                    </a:solidFill>
+                  </a:tcPr>
+                </a:tc>
+                <a:tc>
+                  <a:txBody>
+                    <a:bodyPr wrap="square"/>
+                    <a:lstStyle/>
+                    <a:p>
+                      <a:pPr marL="0" indent="0" algn="ctr">
+                        <a:lnSpc>
+                          <a:spcPct val="100000"/>
+                        </a:lnSpc>
+                        <a:spcBef>
+                          <a:spcPts val="0"/>
+                        </a:spcBef>
+                        <a:spcAft>
+                          <a:spcPts val="0"/>
+                        </a:spcAft>
+                        <a:buNone/>
+                      </a:pPr>
+                      <a:r>
+                        <a:rPr lang="zh-CN" altLang="en-US" sz="1150" b="0" noProof="1">
+                          <a:solidFill>
+                            <a:srgbClr val="262626"/>
+                          </a:solidFill>
+                          <a:latin typeface="Segoe UI"/>
+                          <a:ea typeface="微软雅黑"/>
+                        </a:rPr>
+                        <a:t>—</a:t>
+                      </a:r>
+                    </a:p>
+                  </a:txBody>
+                  <a:tcPr anchor="ctr" marL="54864" marR="54864" marT="27432" marB="27432">
+                    <a:lnL w="0">
+                      <a:noFill/>
+                    </a:lnL>
+                    <a:lnR w="0">
+                      <a:noFill/>
+                    </a:lnR>
+                    <a:lnT w="0">
+                      <a:noFill/>
+                    </a:lnT>
+                    <a:lnB w="15875">
+                      <a:solidFill>
+                        <a:srgbClr val="404040"/>
+                      </a:solidFill>
+                    </a:lnB>
+                    <a:solidFill>
+                      <a:srgbClr val="FFFFFF"/>
+                    </a:solidFill>
+                  </a:tcPr>
+                </a:tc>
+                <a:tc>
+                  <a:txBody>
+                    <a:bodyPr wrap="square"/>
+                    <a:lstStyle/>
+                    <a:p>
+                      <a:pPr marL="0" indent="0" algn="ctr">
+                        <a:lnSpc>
+                          <a:spcPct val="100000"/>
+                        </a:lnSpc>
+                        <a:spcBef>
+                          <a:spcPts val="0"/>
+                        </a:spcBef>
+                        <a:spcAft>
+                          <a:spcPts val="0"/>
+                        </a:spcAft>
+                        <a:buNone/>
+                      </a:pPr>
+                      <a:r>
+                        <a:rPr lang="zh-CN" altLang="en-US" sz="1150" b="0" noProof="1">
+                          <a:solidFill>
+                            <a:srgbClr val="262626"/>
+                          </a:solidFill>
+                          <a:latin typeface="Segoe UI"/>
+                          <a:ea typeface="微软雅黑"/>
+                        </a:rPr>
+                        <a:t>全部通过</a:t>
+                      </a:r>
+                    </a:p>
+                  </a:txBody>
+                  <a:tcPr anchor="ctr" marL="54864" marR="54864" marT="27432" marB="27432">
+                    <a:lnL w="0">
+                      <a:noFill/>
+                    </a:lnL>
+                    <a:lnR w="0">
+                      <a:noFill/>
+                    </a:lnR>
+                    <a:lnT w="0">
+                      <a:noFill/>
+                    </a:lnT>
+                    <a:lnB w="15875">
+                      <a:solidFill>
+                        <a:srgbClr val="404040"/>
+                      </a:solidFill>
+                    </a:lnB>
+                    <a:solidFill>
+                      <a:srgbClr val="FFFFFF"/>
+                    </a:solidFill>
+                  </a:tcPr>
+                </a:tc>
+              </a:tr>
+            </a:tbl>
+          </a:graphicData>
+        </a:graphic>
+      </p:graphicFrame>
+      <p:sp>
+        <p:nvSpPr>
+          <p:cNvPr id="11" name="TextBox 10"/>
+          <p:cNvSpPr txBox="1"/>
+          <p:nvPr/>
+        </p:nvSpPr>
+        <p:spPr>
+          <a:xfrm>
+            <a:off x="649224" y="5952744"/>
+            <a:ext cx="5202936" cy="411480"/>
+          </a:xfrm>
+          <a:prstGeom prst="rect">
+            <a:avLst/>
+          </a:prstGeom>
+          <a:noFill/>
+        </p:spPr>
+        <p:txBody>
+          <a:bodyPr wrap="square" lIns="0" rIns="0" tIns="0" bIns="0">
+            <a:spAutoFit/>
+          </a:bodyPr>
+          <a:lstStyle/>
+          <a:p>
+            <a:pPr marL="0" indent="0">
+              <a:lnSpc>
+                <a:spcPct val="105000"/>
+              </a:lnSpc>
+              <a:spcBef>
+                <a:spcPts val="0"/>
+              </a:spcBef>
+              <a:spcAft>
+                <a:spcPts val="0"/>
+              </a:spcAft>
+              <a:buNone/>
+            </a:pPr>
+            <a:r>
+              <a:rPr lang="zh-CN" altLang="en-US" sz="1100" b="0" noProof="1">
+                <a:solidFill>
+                  <a:srgbClr val="262626"/>
+                </a:solidFill>
+                <a:latin typeface="Segoe UI"/>
+                <a:ea typeface="微软雅黑"/>
+              </a:rPr>
+              <a:t>到 day09 没有成批复读；但训练步数比对照少，且 day08 出现一个 95 turn 的超长轮次（不是复读 thinking），当天 Acc 0。</a:t>
+            </a:r>
+          </a:p>
+        </p:txBody>
+      </p:sp>
+      <p:sp>
+        <p:nvSpPr>
+          <p:cNvPr id="12" name="Panel"/>
+          <p:cNvSpPr/>
+          <p:nvPr/>
+        </p:nvSpPr>
+        <p:spPr>
+          <a:xfrm>
+            <a:off x="6172200" y="3904487"/>
+            <a:ext cx="5532120" cy="2788920"/>
+          </a:xfrm>
+          <a:prstGeom prst="rect">
+            <a:avLst/>
+          </a:prstGeom>
+          <a:solidFill>
+            <a:srgbClr val="FFFFFF"/>
+          </a:solidFill>
+          <a:ln>
+            <a:noFill/>
+          </a:ln>
+          <a:effectLst/>
+        </p:spPr>
+        <p:style>
+          <a:lnRef idx="1">
+            <a:schemeClr val="accent1"/>
+          </a:lnRef>
+          <a:fillRef idx="3">
+            <a:schemeClr val="accent1"/>
+          </a:fillRef>
+          <a:effectRef idx="2">
+            <a:schemeClr val="accent1"/>
+          </a:effectRef>
+          <a:fontRef idx="minor">
+            <a:schemeClr val="lt1"/>
+          </a:fontRef>
+        </p:style>
+        <p:txBody>
+          <a:bodyPr rtlCol="0" anchor="ctr"/>
+          <a:lstStyle/>
+          <a:p>
+            <a:pPr algn="ctr"/>
+          </a:p>
+        </p:txBody>
+      </p:sp>
+      <p:sp>
+        <p:nvSpPr>
+          <p:cNvPr id="13" name="TextBox 12"/>
+          <p:cNvSpPr txBox="1"/>
+          <p:nvPr/>
+        </p:nvSpPr>
+        <p:spPr>
+          <a:xfrm>
+            <a:off x="6336792" y="4014215"/>
+            <a:ext cx="5202936" cy="2606040"/>
+          </a:xfrm>
+          <a:prstGeom prst="rect">
+            <a:avLst/>
+          </a:prstGeom>
+          <a:noFill/>
+        </p:spPr>
+        <p:txBody>
+          <a:bodyPr wrap="square" lIns="0" rIns="0" tIns="0" bIns="0">
+            <a:spAutoFit/>
+          </a:bodyPr>
+          <a:lstStyle/>
+          <a:p>
+            <a:pPr marL="0" indent="0">
+              <a:lnSpc>
+                <a:spcPct val="110000"/>
+              </a:lnSpc>
+              <a:spcBef>
+                <a:spcPts val="0"/>
+              </a:spcBef>
+              <a:spcAft>
+                <a:spcPts val="600"/>
+              </a:spcAft>
+              <a:buNone/>
+            </a:pPr>
+            <a:r>
+              <a:rPr lang="zh-CN" altLang="en-US" sz="1500" b="1" noProof="1">
+                <a:solidFill>
+                  <a:srgbClr val="262626"/>
+                </a:solidFill>
+                <a:latin typeface="Segoe UI"/>
+                <a:ea typeface="微软雅黑"/>
+              </a:rPr>
+              <a:t>④ 当前：从头重跑</a:t>
+            </a:r>
+          </a:p>
+          <a:p>
+            <a:pPr marL="0" indent="0">
+              <a:lnSpc>
+                <a:spcPct val="110000"/>
+              </a:lnSpc>
+              <a:spcBef>
+                <a:spcPts val="0"/>
+              </a:spcBef>
+              <a:spcAft>
+                <a:spcPts val="400"/>
+              </a:spcAft>
+              <a:buNone/>
+            </a:pPr>
+            <a:r>
+              <a:rPr lang="zh-CN" altLang="en-US" sz="1250" b="0" noProof="1">
+                <a:solidFill>
+                  <a:srgbClr val="262626"/>
+                </a:solidFill>
+                <a:latin typeface="Segoe UI"/>
+                <a:ea typeface="微软雅黑"/>
+              </a:rPr>
+              <a:t>· 首趟 driver 在 day10 中途退出，只训练到 step 8；checkpoint 每 10 步才存一次，无法续跑</a:t>
+            </a:r>
+          </a:p>
+          <a:p>
+            <a:pPr marL="0" indent="0">
+              <a:lnSpc>
+                <a:spcPct val="110000"/>
+              </a:lnSpc>
+              <a:spcBef>
+                <a:spcPts val="0"/>
+              </a:spcBef>
+              <a:spcAft>
+                <a:spcPts val="400"/>
+              </a:spcAft>
+              <a:buNone/>
+            </a:pPr>
+            <a:r>
+              <a:rPr lang="zh-CN" altLang="en-US" sz="1250" b="0" noProof="1">
+                <a:solidFill>
+                  <a:srgbClr val="262626"/>
+                </a:solidFill>
+                <a:latin typeface="Segoe UI"/>
+                <a:ea typeface="微软雅黑"/>
+              </a:rPr>
+              <a:t>· 同策略会丢掉训练期间产生的样本，约每天 1 步，大约到 day13 才达到对照起病时的步数（step 11）</a:t>
+            </a:r>
+          </a:p>
+          <a:p>
+            <a:pPr marL="0" indent="0">
+              <a:lnSpc>
+                <a:spcPct val="110000"/>
+              </a:lnSpc>
+              <a:spcBef>
+                <a:spcPts val="0"/>
+              </a:spcBef>
+              <a:spcAft>
+                <a:spcPts val="0"/>
+              </a:spcAft>
+              <a:buNone/>
+            </a:pPr>
+            <a:r>
+              <a:rPr lang="zh-CN" altLang="en-US" sz="1250" b="1" noProof="1">
+                <a:solidFill>
+                  <a:srgbClr val="262626"/>
+                </a:solidFill>
+                <a:latin typeface="Segoe UI"/>
+                <a:ea typeface="微软雅黑"/>
+              </a:rPr>
+              <a:t>· 判据（提议，按训练步数对齐）：</a:t>
+            </a:r>
+            <a:r>
+              <a:rPr lang="zh-CN" altLang="en-US" sz="1250" b="0" noProof="1">
+                <a:solidFill>
+                  <a:srgbClr val="262626"/>
+                </a:solidFill>
+                <a:latin typeface="Segoe UI"/>
+                <a:ea typeface="微软雅黑"/>
+              </a:rPr>
+              <a:t>训练到 step 15、且 day13 之前每天复读占比都 &lt; 25% → H-f 成立；step 12 及以前出现 ≥ 25% 的一天 → 不成立；其余不下结论</a:t>
+            </a:r>
+          </a:p>
+        </p:txBody>
+      </p:sp>
     </p:spTree>
   </p:cSld>
   <p:clrMapOvr>
@@ -17126,7 +18659,7 @@
                 <a:latin typeface="Segoe UI"/>
                 <a:ea typeface="微软雅黑"/>
               </a:rPr>
-              <a:t>结果：未定论</a:t>
+              <a:t>结果：未定论（正在重跑，见第 10 页）</a:t>
             </a:r>
           </a:p>
           <a:p>

</xml_diff>